<commit_message>
docs(pptx): fix LAN8651 timestamping signal path order on slide 18
The previous diagram showed SPI readout before nIRQ, which is wrong.
Correct order: MAC timestamp latch → nIRQ → ISR (captures SYS_TIME
SW-timestamp, signals TC6 driver) → SPI readout.  The ISR is where
the SFD moment is paired with MCU time semi-deterministically; SPI
transfer happens later and is not on the timing-critical path.

Co-Authored-By: Claude Opus 4.7 (1M context) <noreply@anthropic.com>
</commit_message>
<xml_diff>
--- a/PTP_LAN8651.pptx
+++ b/PTP_LAN8651.pptx
@@ -6316,8 +6316,8 @@
         </p:nvSpPr>
         <p:spPr>
           <a:xfrm>
-            <a:off x="548640" y="1920240"/>
-            <a:ext cx="1920240" cy="914400"/>
+            <a:off x="320040" y="1920240"/>
+            <a:ext cx="1737360" cy="914400"/>
           </a:xfrm>
           <a:prstGeom prst="roundRect">
             <a:avLst/>
@@ -6351,7 +6351,7 @@
           <a:p>
             <a:pPr algn="l"/>
             <a:r>
-              <a:rPr sz="1300" b="1" i="0">
+              <a:rPr sz="1200" b="1" i="0">
                 <a:solidFill>
                   <a:srgbClr val="FFFFFF"/>
                 </a:solidFill>
@@ -6370,8 +6370,8 @@
         </p:nvSpPr>
         <p:spPr>
           <a:xfrm>
-            <a:off x="2743200" y="1920240"/>
-            <a:ext cx="1920240" cy="914400"/>
+            <a:off x="2286000" y="1920240"/>
+            <a:ext cx="1828800" cy="914400"/>
           </a:xfrm>
           <a:prstGeom prst="roundRect">
             <a:avLst/>
@@ -6405,7 +6405,7 @@
           <a:p>
             <a:pPr algn="l"/>
             <a:r>
-              <a:rPr sz="1300" b="1" i="0">
+              <a:rPr sz="1200" b="1" i="0">
                 <a:solidFill>
                   <a:srgbClr val="FFFFFF"/>
                 </a:solidFill>
@@ -6424,8 +6424,8 @@
         </p:nvSpPr>
         <p:spPr>
           <a:xfrm>
-            <a:off x="4937760" y="1920240"/>
-            <a:ext cx="1920240" cy="914400"/>
+            <a:off x="4343400" y="1920240"/>
+            <a:ext cx="1828800" cy="914400"/>
           </a:xfrm>
           <a:prstGeom prst="roundRect">
             <a:avLst/>
@@ -6459,7 +6459,7 @@
           <a:p>
             <a:pPr algn="l"/>
             <a:r>
-              <a:rPr sz="1300" b="1" i="0">
+              <a:rPr sz="1200" b="1" i="0">
                 <a:solidFill>
                   <a:srgbClr val="FFFFFF"/>
                 </a:solidFill>
@@ -6478,8 +6478,62 @@
         </p:nvSpPr>
         <p:spPr>
           <a:xfrm>
-            <a:off x="7132320" y="1920240"/>
-            <a:ext cx="1920240" cy="914400"/>
+            <a:off x="6400800" y="1920240"/>
+            <a:ext cx="1737360" cy="914400"/>
+          </a:xfrm>
+          <a:prstGeom prst="roundRect">
+            <a:avLst/>
+          </a:prstGeom>
+          <a:solidFill>
+            <a:srgbClr val="D62728"/>
+          </a:solidFill>
+          <a:ln>
+            <a:solidFill>
+              <a:srgbClr val="D62728"/>
+            </a:solidFill>
+          </a:ln>
+        </p:spPr>
+        <p:style>
+          <a:lnRef idx="1">
+            <a:schemeClr val="accent1"/>
+          </a:lnRef>
+          <a:fillRef idx="3">
+            <a:schemeClr val="accent1"/>
+          </a:fillRef>
+          <a:effectRef idx="2">
+            <a:schemeClr val="accent1"/>
+          </a:effectRef>
+          <a:fontRef idx="minor">
+            <a:schemeClr val="lt1"/>
+          </a:fontRef>
+        </p:style>
+        <p:txBody>
+          <a:bodyPr rtlCol="0" anchor="ctr" wrap="square"/>
+          <a:lstStyle/>
+          <a:p>
+            <a:pPr algn="l"/>
+            <a:r>
+              <a:rPr sz="1200" b="1" i="0">
+                <a:solidFill>
+                  <a:srgbClr val="FFFFFF"/>
+                </a:solidFill>
+              </a:rPr>
+              <a:t>nIRQ
+to MCU</a:t>
+            </a:r>
+          </a:p>
+        </p:txBody>
+      </p:sp>
+      <p:sp>
+        <p:nvSpPr>
+          <p:cNvPr id="7" name="Rounded Rectangle 6"/>
+          <p:cNvSpPr/>
+          <p:nvPr/>
+        </p:nvSpPr>
+        <p:spPr>
+          <a:xfrm>
+            <a:off x="8366760" y="1920240"/>
+            <a:ext cx="2011680" cy="914400"/>
           </a:xfrm>
           <a:prstGeom prst="roundRect">
             <a:avLst/>
@@ -6513,37 +6567,37 @@
           <a:p>
             <a:pPr algn="l"/>
             <a:r>
-              <a:rPr sz="1300" b="1" i="0">
+              <a:rPr sz="1200" b="1" i="0">
                 <a:solidFill>
                   <a:srgbClr val="FFFFFF"/>
                 </a:solidFill>
               </a:rPr>
-              <a:t>SPI readout
-to MCU</a:t>
-            </a:r>
-          </a:p>
-        </p:txBody>
-      </p:sp>
-      <p:sp>
-        <p:nvSpPr>
-          <p:cNvPr id="7" name="Rounded Rectangle 6"/>
+              <a:t>ISR: SW-TS +
+signal TC6</a:t>
+            </a:r>
+          </a:p>
+        </p:txBody>
+      </p:sp>
+      <p:sp>
+        <p:nvSpPr>
+          <p:cNvPr id="8" name="Rounded Rectangle 7"/>
           <p:cNvSpPr/>
           <p:nvPr/>
         </p:nvSpPr>
         <p:spPr>
           <a:xfrm>
-            <a:off x="9326880" y="1920240"/>
-            <a:ext cx="1920240" cy="914400"/>
+            <a:off x="10607040" y="1920240"/>
+            <a:ext cx="1280160" cy="914400"/>
           </a:xfrm>
           <a:prstGeom prst="roundRect">
             <a:avLst/>
           </a:prstGeom>
           <a:solidFill>
-            <a:srgbClr val="D62728"/>
+            <a:srgbClr val="0B2E4F"/>
           </a:solidFill>
           <a:ln>
             <a:solidFill>
-              <a:srgbClr val="D62728"/>
+              <a:srgbClr val="0B2E4F"/>
             </a:solidFill>
           </a:ln>
         </p:spPr>
@@ -6567,52 +6621,17 @@
           <a:p>
             <a:pPr algn="l"/>
             <a:r>
-              <a:rPr sz="1300" b="1" i="0">
+              <a:rPr sz="1200" b="1" i="0">
                 <a:solidFill>
                   <a:srgbClr val="FFFFFF"/>
                 </a:solidFill>
               </a:rPr>
-              <a:t>nIRQ
-to MCU</a:t>
-            </a:r>
-          </a:p>
-        </p:txBody>
-      </p:sp>
-      <p:cxnSp>
-        <p:nvCxnSpPr>
-          <p:cNvPr id="8" name="Connector 7"/>
-          <p:cNvCxnSpPr/>
-          <p:nvPr/>
-        </p:nvCxnSpPr>
-        <p:spPr>
-          <a:xfrm>
-            <a:off x="2468880" y="2377440"/>
-            <a:ext cx="274320" cy="0"/>
-          </a:xfrm>
-          <a:prstGeom prst="bentConnector3">
-            <a:avLst/>
-          </a:prstGeom>
-          <a:ln w="25400">
-            <a:solidFill>
-              <a:srgbClr val="555555"/>
-            </a:solidFill>
-          </a:ln>
-        </p:spPr>
-        <p:style>
-          <a:lnRef idx="2">
-            <a:schemeClr val="accent1"/>
-          </a:lnRef>
-          <a:fillRef idx="0">
-            <a:schemeClr val="accent1"/>
-          </a:fillRef>
-          <a:effectRef idx="1">
-            <a:schemeClr val="accent1"/>
-          </a:effectRef>
-          <a:fontRef idx="minor">
-            <a:schemeClr val="tx1"/>
-          </a:fontRef>
-        </p:style>
-      </p:cxnSp>
+              <a:t>SPI
+readout</a:t>
+            </a:r>
+          </a:p>
+        </p:txBody>
+      </p:sp>
       <p:cxnSp>
         <p:nvCxnSpPr>
           <p:cNvPr id="9" name="Connector 8"/>
@@ -6621,8 +6640,8 @@
         </p:nvCxnSpPr>
         <p:spPr>
           <a:xfrm>
-            <a:off x="4663440" y="2377440"/>
-            <a:ext cx="274319" cy="0"/>
+            <a:off x="2057400" y="2377440"/>
+            <a:ext cx="228600" cy="0"/>
           </a:xfrm>
           <a:prstGeom prst="bentConnector3">
             <a:avLst/>
@@ -6656,8 +6675,8 @@
         </p:nvCxnSpPr>
         <p:spPr>
           <a:xfrm>
-            <a:off x="6858000" y="2377440"/>
-            <a:ext cx="274320" cy="0"/>
+            <a:off x="4114800" y="2377440"/>
+            <a:ext cx="228600" cy="0"/>
           </a:xfrm>
           <a:prstGeom prst="bentConnector3">
             <a:avLst/>
@@ -6691,8 +6710,8 @@
         </p:nvCxnSpPr>
         <p:spPr>
           <a:xfrm>
-            <a:off x="9052560" y="2377440"/>
-            <a:ext cx="274320" cy="0"/>
+            <a:off x="6172200" y="2377440"/>
+            <a:ext cx="228600" cy="0"/>
           </a:xfrm>
           <a:prstGeom prst="bentConnector3">
             <a:avLst/>
@@ -6718,16 +6737,86 @@
           </a:fontRef>
         </p:style>
       </p:cxnSp>
-      <p:sp>
-        <p:nvSpPr>
-          <p:cNvPr id="12" name="TextBox 11"/>
+      <p:cxnSp>
+        <p:nvCxnSpPr>
+          <p:cNvPr id="12" name="Connector 11"/>
+          <p:cNvCxnSpPr/>
+          <p:nvPr/>
+        </p:nvCxnSpPr>
+        <p:spPr>
+          <a:xfrm>
+            <a:off x="8138160" y="2377440"/>
+            <a:ext cx="228600" cy="0"/>
+          </a:xfrm>
+          <a:prstGeom prst="bentConnector3">
+            <a:avLst/>
+          </a:prstGeom>
+          <a:ln w="25400">
+            <a:solidFill>
+              <a:srgbClr val="555555"/>
+            </a:solidFill>
+          </a:ln>
+        </p:spPr>
+        <p:style>
+          <a:lnRef idx="2">
+            <a:schemeClr val="accent1"/>
+          </a:lnRef>
+          <a:fillRef idx="0">
+            <a:schemeClr val="accent1"/>
+          </a:fillRef>
+          <a:effectRef idx="1">
+            <a:schemeClr val="accent1"/>
+          </a:effectRef>
+          <a:fontRef idx="minor">
+            <a:schemeClr val="tx1"/>
+          </a:fontRef>
+        </p:style>
+      </p:cxnSp>
+      <p:cxnSp>
+        <p:nvCxnSpPr>
+          <p:cNvPr id="13" name="Connector 12"/>
+          <p:cNvCxnSpPr/>
+          <p:nvPr/>
+        </p:nvCxnSpPr>
+        <p:spPr>
+          <a:xfrm>
+            <a:off x="10378440" y="2377440"/>
+            <a:ext cx="228600" cy="0"/>
+          </a:xfrm>
+          <a:prstGeom prst="bentConnector3">
+            <a:avLst/>
+          </a:prstGeom>
+          <a:ln w="25400">
+            <a:solidFill>
+              <a:srgbClr val="555555"/>
+            </a:solidFill>
+          </a:ln>
+        </p:spPr>
+        <p:style>
+          <a:lnRef idx="2">
+            <a:schemeClr val="accent1"/>
+          </a:lnRef>
+          <a:fillRef idx="0">
+            <a:schemeClr val="accent1"/>
+          </a:fillRef>
+          <a:effectRef idx="1">
+            <a:schemeClr val="accent1"/>
+          </a:effectRef>
+          <a:fontRef idx="minor">
+            <a:schemeClr val="tx1"/>
+          </a:fontRef>
+        </p:style>
+      </p:cxnSp>
+      <p:sp>
+        <p:nvSpPr>
+          <p:cNvPr id="14" name="TextBox 13"/>
           <p:cNvSpPr txBox="1"/>
           <p:nvPr/>
         </p:nvSpPr>
         <p:spPr>
           <a:xfrm>
-            <a:off x="548640" y="3108960"/>
-            <a:ext cx="10972800" cy="3200400"/>
+            <a:off x="457200" y="3108960"/>
+            <a:ext cx="11247120" cy="3200400"/>
           </a:xfrm>
           <a:prstGeom prst="rect">
             <a:avLst/>
@@ -6741,52 +6830,62 @@
           <a:lstStyle/>
           <a:p>
             <a:r>
-              <a:rPr sz="1600">
+              <a:rPr sz="1400">
                 <a:solidFill>
                   <a:srgbClr val="0B2E4F"/>
                 </a:solidFill>
               </a:rPr>
-              <a:t>• TX path: MCU writes frame over SPI → MAC transmits → SFD on wire = t1 latched</a:t>
-            </a:r>
-          </a:p>
-          <a:p>
-            <a:r>
-              <a:rPr sz="1600">
+              <a:t>• MAC latches the hardware timestamp on the SFD bit — that is the 'ground truth' moment.</a:t>
+            </a:r>
+          </a:p>
+          <a:p>
+            <a:r>
+              <a:rPr sz="1400">
                 <a:solidFill>
                   <a:srgbClr val="0B2E4F"/>
                 </a:solidFill>
               </a:rPr>
-              <a:t>• RX path: SFD on wire = t2 latched → MAC stores timestamp → nIRQ → MCU reads over SPI</a:t>
-            </a:r>
-          </a:p>
-          <a:p>
-            <a:r>
-              <a:rPr sz="1600">
+              <a:t>• LAN8651 then asserts nIRQ to the MCU.</a:t>
+            </a:r>
+          </a:p>
+          <a:p>
+            <a:r>
+              <a:rPr sz="1400">
                 <a:solidFill>
                   <a:srgbClr val="0B2E4F"/>
                 </a:solidFill>
               </a:rPr>
-              <a:t>• TX: ~800 µs from SFD-on-wire to the TX-timestamp-available nIRQ  (pipeline + SPI)</a:t>
-            </a:r>
-          </a:p>
-          <a:p>
-            <a:r>
-              <a:rPr sz="1600">
+              <a:t>• In the nIRQ ISR the driver captures the internal SW timestamp (SYS_TIME tick) — pairs SFD with MCU time, semi-deterministic.</a:t>
+            </a:r>
+          </a:p>
+          <a:p>
+            <a:r>
+              <a:rPr sz="1400">
                 <a:solidFill>
                   <a:srgbClr val="0B2E4F"/>
                 </a:solidFill>
               </a:rPr>
-              <a:t>• RX: ~10 ms from SFD-on-wire to the RX-nIRQ   (LAN8651 behaviour)</a:t>
-            </a:r>
-          </a:p>
-          <a:p>
-            <a:r>
-              <a:rPr sz="1600">
+              <a:t>• The ISR then signals the TC6 driver layer, which later performs the SPI transfer that carries the frame and the HW timestamp to the host.</a:t>
+            </a:r>
+          </a:p>
+          <a:p>
+            <a:r>
+              <a:rPr sz="1400">
                 <a:solidFill>
                   <a:srgbClr val="0B2E4F"/>
                 </a:solidFill>
               </a:rPr>
-              <a:t>• Both biases must be compensated outside PTP — protocol cannot see them</a:t>
+              <a:t>• RX bias: ~10 ms from SFD-on-wire to the RX-nIRQ assertion on the LAN8651 — compensated outside PTP (PTP_FOL_ANCHOR_OFFSET_NS).</a:t>
+            </a:r>
+          </a:p>
+          <a:p>
+            <a:r>
+              <a:rPr sz="1400">
+                <a:solidFill>
+                  <a:srgbClr val="0B2E4F"/>
+                </a:solidFill>
+              </a:rPr>
+              <a:t>• TX bias: ~800 µs from SFD-on-wire to TX-timestamp nIRQ — compensated via PTP_GM_ANCHOR_OFFSET_NS.</a:t>
             </a:r>
           </a:p>
         </p:txBody>

</xml_diff>